<commit_message>
Rewrite Dickey Law Group proposal deck with DBM language
- All four DBM touchpoints populated: GOAL_DBM, SMB_MODEL_DESC,
  CLOSING_QUOTE, and at least one outcome-framed bullet per priority column
- Closing quote in client voice: built around the freedom/community motive
- Staircase set to Stage 3 (Solo Practitioner); strikethrough dark (#334155);
  website screenshot skipped per updated template
- Prices exact from section_11: $4,847 / $3,200 bundled, $8,047 total

https://claude.ai/code/session_013MDLDGdmxxHB21zUAgdWp5
</commit_message>
<xml_diff>
--- a/dickey-law-group/Dickey_Law_Group_May_18_2026_Proposal.pptx
+++ b/dickey-law-group/Dickey_Law_Group_May_18_2026_Proposal.pptx
@@ -3496,7 +3496,7 @@
                 </a:solidFill>
                 <a:latin typeface="Calibri"/>
               </a:rPr>
-              <a:t>0% paid traffic</a:t>
+              <a:t>100% organic, 0% paid</a:t>
             </a:r>
           </a:p>
         </p:txBody>
@@ -3685,7 +3685,7 @@
                 </a:solidFill>
                 <a:latin typeface="Calibri"/>
               </a:rPr>
-              <a:t>Attorneys handle intake</a:t>
+              <a:t>No intake staff</a:t>
             </a:r>
           </a:p>
         </p:txBody>
@@ -4030,7 +4030,7 @@
                 </a:solidFill>
                 <a:latin typeface="Calibri"/>
               </a:rPr>
-              <a:t>AMBER</a:t>
+              <a:t>MONITOR</a:t>
             </a:r>
           </a:p>
         </p:txBody>
@@ -4063,7 +4063,7 @@
                 </a:solidFill>
                 <a:latin typeface="Calibri"/>
               </a:rPr>
-              <a:t>Margins unknown</a:t>
+              <a:t>No profit tracking</a:t>
             </a:r>
           </a:p>
         </p:txBody>
@@ -4252,7 +4252,7 @@
                 </a:solidFill>
                 <a:latin typeface="Calibri"/>
               </a:rPr>
-              <a:t>No paid advertising — invisible to high-intent searchers in The Woodlands</a:t>
+              <a:t>Zero paid ads — invisible to high-intent local searchers</a:t>
             </a:r>
           </a:p>
         </p:txBody>
@@ -4408,7 +4408,7 @@
                 </a:solidFill>
                 <a:latin typeface="Calibri"/>
               </a:rPr>
-              <a:t>Attorneys handle all intake personally — bottleneck at highest cost point</a:t>
+              <a:t>Intake falls to both attorneys — no after-hours coverage</a:t>
             </a:r>
           </a:p>
         </p:txBody>
@@ -4564,7 +4564,7 @@
                 </a:solidFill>
                 <a:latin typeface="Calibri"/>
               </a:rPr>
-              <a:t>2-attorney firm, no staff — growth capped at personal capacity</a:t>
+              <a:t>Two-attorney firm can't scale without systems and staff</a:t>
             </a:r>
           </a:p>
         </p:txBody>
@@ -4720,7 +4720,7 @@
                 </a:solidFill>
                 <a:latin typeface="Calibri"/>
               </a:rPr>
-              <a:t>32 five-star reviews + active bilingual blog — strong organic foundation</a:t>
+              <a:t>5-star bilingual firm — a rare trust edge competitors lack</a:t>
             </a:r>
           </a:p>
         </p:txBody>
@@ -4778,84 +4778,6 @@
         </p:nvSpPr>
         <p:spPr>
           <a:xfrm>
-            <a:off x="5321808" y="109728"/>
-            <a:ext cx="3749039" cy="2112264"/>
-          </a:xfrm>
-          <a:prstGeom prst="rect">
-            <a:avLst/>
-          </a:prstGeom>
-          <a:solidFill>
-            <a:srgbClr val="D1D5DB"/>
-          </a:solidFill>
-          <a:ln>
-            <a:solidFill>
-              <a:srgbClr val="FFFFFF"/>
-            </a:solidFill>
-          </a:ln>
-        </p:spPr>
-        <p:style>
-          <a:lnRef idx="1">
-            <a:schemeClr val="accent1"/>
-          </a:lnRef>
-          <a:fillRef idx="3">
-            <a:schemeClr val="accent1"/>
-          </a:fillRef>
-          <a:effectRef idx="2">
-            <a:schemeClr val="accent1"/>
-          </a:effectRef>
-          <a:fontRef idx="minor">
-            <a:schemeClr val="lt1"/>
-          </a:fontRef>
-        </p:style>
-        <p:txBody>
-          <a:bodyPr rtlCol="0" anchor="ctr"/>
-          <a:lstStyle/>
-          <a:p>
-            <a:pPr algn="ctr"/>
-          </a:p>
-        </p:txBody>
-      </p:sp>
-      <p:sp>
-        <p:nvSpPr>
-          <p:cNvPr id="47" name="TextBox 46"/>
-          <p:cNvSpPr txBox="1"/>
-          <p:nvPr/>
-        </p:nvSpPr>
-        <p:spPr>
-          <a:xfrm>
-            <a:off x="5367528" y="1056131"/>
-            <a:ext cx="3657599" cy="219456"/>
-          </a:xfrm>
-          <a:prstGeom prst="rect">
-            <a:avLst/>
-          </a:prstGeom>
-          <a:noFill/>
-        </p:spPr>
-        <p:txBody>
-          <a:bodyPr wrap="square"/>
-          <a:lstStyle/>
-          <a:p>
-            <a:pPr algn="ctr"/>
-            <a:r>
-              <a:rPr sz="700" b="0" i="0">
-                <a:solidFill>
-                  <a:srgbClr val="64748B"/>
-                </a:solidFill>
-                <a:latin typeface="Calibri"/>
-              </a:rPr>
-              <a:t>Website Screenshot</a:t>
-            </a:r>
-          </a:p>
-        </p:txBody>
-      </p:sp>
-      <p:sp>
-        <p:nvSpPr>
-          <p:cNvPr id="48" name="Rectangle 47"/>
-          <p:cNvSpPr/>
-          <p:nvPr/>
-        </p:nvSpPr>
-        <p:spPr>
-          <a:xfrm>
             <a:off x="5257800" y="2267712"/>
             <a:ext cx="3886200" cy="694944"/>
           </a:xfrm>
@@ -4895,7 +4817,7 @@
       </p:sp>
       <p:sp>
         <p:nvSpPr>
-          <p:cNvPr id="49" name="Rectangle 48"/>
+          <p:cNvPr id="47" name="Rectangle 46"/>
           <p:cNvSpPr/>
           <p:nvPr/>
         </p:nvSpPr>
@@ -4940,7 +4862,7 @@
       </p:sp>
       <p:sp>
         <p:nvSpPr>
-          <p:cNvPr id="50" name="TextBox 49"/>
+          <p:cNvPr id="48" name="TextBox 47"/>
           <p:cNvSpPr txBox="1"/>
           <p:nvPr/>
         </p:nvSpPr>
@@ -4973,7 +4895,7 @@
       </p:sp>
       <p:sp>
         <p:nvSpPr>
-          <p:cNvPr id="51" name="TextBox 50"/>
+          <p:cNvPr id="49" name="TextBox 48"/>
           <p:cNvSpPr txBox="1"/>
           <p:nvPr/>
         </p:nvSpPr>
@@ -4999,14 +4921,14 @@
                 </a:solidFill>
                 <a:latin typeface="Calibri"/>
               </a:rPr>
-              <a:t>Stage 3: Solo Practitioner  →  Goal: Stage 6, Law Firm Owner</a:t>
-            </a:r>
-          </a:p>
-        </p:txBody>
-      </p:sp>
-      <p:sp>
-        <p:nvSpPr>
-          <p:cNvPr id="52" name="TextBox 51"/>
+              <a:t>Stage 3: Solo Practitioner  →  Goal: Stage 5, Law Firm CEO</a:t>
+            </a:r>
+          </a:p>
+        </p:txBody>
+      </p:sp>
+      <p:sp>
+        <p:nvSpPr>
+          <p:cNvPr id="50" name="TextBox 49"/>
           <p:cNvSpPr txBox="1"/>
           <p:nvPr/>
         </p:nvSpPr>
@@ -5039,7 +4961,7 @@
       </p:sp>
       <p:sp>
         <p:nvSpPr>
-          <p:cNvPr id="53" name="Rectangle 52"/>
+          <p:cNvPr id="51" name="Rectangle 50"/>
           <p:cNvSpPr/>
           <p:nvPr/>
         </p:nvSpPr>
@@ -5084,7 +5006,7 @@
       </p:sp>
       <p:sp>
         <p:nvSpPr>
-          <p:cNvPr id="54" name="TextBox 53"/>
+          <p:cNvPr id="52" name="TextBox 51"/>
           <p:cNvSpPr txBox="1"/>
           <p:nvPr/>
         </p:nvSpPr>
@@ -5117,7 +5039,7 @@
       </p:sp>
       <p:sp>
         <p:nvSpPr>
-          <p:cNvPr id="55" name="TextBox 54"/>
+          <p:cNvPr id="53" name="TextBox 52"/>
           <p:cNvSpPr txBox="1"/>
           <p:nvPr/>
         </p:nvSpPr>
@@ -5143,14 +5065,14 @@
                 </a:solidFill>
                 <a:latin typeface="Calibri"/>
               </a:rPr>
-              <a:t>Avvo 9.6–10.0</a:t>
-            </a:r>
-          </a:p>
-        </p:txBody>
-      </p:sp>
-      <p:sp>
-        <p:nvSpPr>
-          <p:cNvPr id="56" name="TextBox 55"/>
+              <a:t>80+ yr track record</a:t>
+            </a:r>
+          </a:p>
+        </p:txBody>
+      </p:sp>
+      <p:sp>
+        <p:nvSpPr>
+          <p:cNvPr id="54" name="TextBox 53"/>
           <p:cNvSpPr txBox="1"/>
           <p:nvPr/>
         </p:nvSpPr>
@@ -5176,14 +5098,14 @@
                 </a:solidFill>
                 <a:latin typeface="Calibri"/>
               </a:rPr>
-              <a:t>80+ yrs exp. · CPA referral network</a:t>
-            </a:r>
-          </a:p>
-        </p:txBody>
-      </p:sp>
-      <p:sp>
-        <p:nvSpPr>
-          <p:cNvPr id="57" name="Rectangle 56"/>
+              <a:t>Top CPA referral source</a:t>
+            </a:r>
+          </a:p>
+        </p:txBody>
+      </p:sp>
+      <p:sp>
+        <p:nvSpPr>
+          <p:cNvPr id="55" name="Rectangle 54"/>
           <p:cNvSpPr/>
           <p:nvPr/>
         </p:nvSpPr>
@@ -5228,7 +5150,7 @@
       </p:sp>
       <p:sp>
         <p:nvSpPr>
-          <p:cNvPr id="58" name="TextBox 57"/>
+          <p:cNvPr id="56" name="TextBox 55"/>
           <p:cNvSpPr txBox="1"/>
           <p:nvPr/>
         </p:nvSpPr>
@@ -5261,7 +5183,7 @@
       </p:sp>
       <p:sp>
         <p:nvSpPr>
-          <p:cNvPr id="59" name="TextBox 58"/>
+          <p:cNvPr id="57" name="TextBox 56"/>
           <p:cNvSpPr txBox="1"/>
           <p:nvPr/>
         </p:nvSpPr>
@@ -5294,7 +5216,7 @@
       </p:sp>
       <p:sp>
         <p:nvSpPr>
-          <p:cNvPr id="60" name="TextBox 59"/>
+          <p:cNvPr id="58" name="TextBox 57"/>
           <p:cNvSpPr txBox="1"/>
           <p:nvPr/>
         </p:nvSpPr>
@@ -5320,14 +5242,14 @@
                 </a:solidFill>
                 <a:latin typeface="Calibri"/>
               </a:rPr>
-              <a:t>Flat-fee · Wills &amp; Waffles events</a:t>
-            </a:r>
-          </a:p>
-        </p:txBody>
-      </p:sp>
-      <p:sp>
-        <p:nvSpPr>
-          <p:cNvPr id="61" name="Rectangle 60"/>
+              <a:t>Flat-fee brand, community events</a:t>
+            </a:r>
+          </a:p>
+        </p:txBody>
+      </p:sp>
+      <p:sp>
+        <p:nvSpPr>
+          <p:cNvPr id="59" name="Rectangle 58"/>
           <p:cNvSpPr/>
           <p:nvPr/>
         </p:nvSpPr>
@@ -5372,7 +5294,7 @@
       </p:sp>
       <p:sp>
         <p:nvSpPr>
-          <p:cNvPr id="62" name="TextBox 61"/>
+          <p:cNvPr id="60" name="TextBox 59"/>
           <p:cNvSpPr txBox="1"/>
           <p:nvPr/>
         </p:nvSpPr>
@@ -5405,7 +5327,7 @@
       </p:sp>
       <p:sp>
         <p:nvSpPr>
-          <p:cNvPr id="63" name="TextBox 62"/>
+          <p:cNvPr id="61" name="TextBox 60"/>
           <p:cNvSpPr txBox="1"/>
           <p:nvPr/>
         </p:nvSpPr>
@@ -5438,7 +5360,7 @@
       </p:sp>
       <p:sp>
         <p:nvSpPr>
-          <p:cNvPr id="64" name="TextBox 63"/>
+          <p:cNvPr id="62" name="TextBox 61"/>
           <p:cNvSpPr txBox="1"/>
           <p:nvPr/>
         </p:nvSpPr>
@@ -5464,14 +5386,14 @@
                 </a:solidFill>
                 <a:latin typeface="Calibri"/>
               </a:rPr>
-              <a:t>25+ yrs · estate + family + probate</a:t>
-            </a:r>
-          </a:p>
-        </p:txBody>
-      </p:sp>
-      <p:sp>
-        <p:nvSpPr>
-          <p:cNvPr id="65" name="Rectangle 64"/>
+              <a:t>25+ yrs, high-volume capacity</a:t>
+            </a:r>
+          </a:p>
+        </p:txBody>
+      </p:sp>
+      <p:sp>
+        <p:nvSpPr>
+          <p:cNvPr id="63" name="Rectangle 62"/>
           <p:cNvSpPr/>
           <p:nvPr/>
         </p:nvSpPr>
@@ -5516,7 +5438,7 @@
       </p:sp>
       <p:sp>
         <p:nvSpPr>
-          <p:cNvPr id="66" name="Rectangle 65"/>
+          <p:cNvPr id="64" name="Rectangle 63"/>
           <p:cNvSpPr/>
           <p:nvPr/>
         </p:nvSpPr>
@@ -5561,7 +5483,7 @@
       </p:sp>
       <p:sp>
         <p:nvSpPr>
-          <p:cNvPr id="67" name="TextBox 66"/>
+          <p:cNvPr id="65" name="TextBox 64"/>
           <p:cNvSpPr txBox="1"/>
           <p:nvPr/>
         </p:nvSpPr>
@@ -5594,7 +5516,7 @@
       </p:sp>
       <p:sp>
         <p:nvSpPr>
-          <p:cNvPr id="68" name="TextBox 67"/>
+          <p:cNvPr id="66" name="TextBox 65"/>
           <p:cNvSpPr txBox="1"/>
           <p:nvPr/>
         </p:nvSpPr>
@@ -5620,14 +5542,14 @@
                 </a:solidFill>
                 <a:latin typeface="Calibri"/>
               </a:rPr>
-              <a:t>32 reviews · 5.0 stars</a:t>
-            </a:r>
-          </a:p>
-        </p:txBody>
-      </p:sp>
-      <p:sp>
-        <p:nvSpPr>
-          <p:cNvPr id="69" name="TextBox 68"/>
+              <a:t>32 reviews</a:t>
+            </a:r>
+          </a:p>
+        </p:txBody>
+      </p:sp>
+      <p:sp>
+        <p:nvSpPr>
+          <p:cNvPr id="67" name="TextBox 66"/>
           <p:cNvSpPr txBox="1"/>
           <p:nvPr/>
         </p:nvSpPr>
@@ -5660,7 +5582,7 @@
       </p:sp>
       <p:sp>
         <p:nvSpPr>
-          <p:cNvPr id="70" name="Rectangle 69"/>
+          <p:cNvPr id="68" name="Rectangle 67"/>
           <p:cNvSpPr/>
           <p:nvPr/>
         </p:nvSpPr>
@@ -5705,7 +5627,7 @@
       </p:sp>
       <p:pic>
         <p:nvPicPr>
-          <p:cNvPr id="71" name="Picture 70" descr="smb_team_logo.png"/>
+          <p:cNvPr id="69" name="Picture 68" descr="smb_team_logo.png"/>
           <p:cNvPicPr>
             <a:picLocks noChangeAspect="1"/>
           </p:cNvPicPr>
@@ -5729,7 +5651,7 @@
       </p:pic>
       <p:sp>
         <p:nvSpPr>
-          <p:cNvPr id="72" name="TextBox 71"/>
+          <p:cNvPr id="70" name="TextBox 69"/>
           <p:cNvSpPr txBox="1"/>
           <p:nvPr/>
         </p:nvSpPr>
@@ -5762,7 +5684,7 @@
       </p:sp>
       <p:sp>
         <p:nvSpPr>
-          <p:cNvPr id="73" name="TextBox 72"/>
+          <p:cNvPr id="71" name="TextBox 70"/>
           <p:cNvSpPr txBox="1"/>
           <p:nvPr/>
         </p:nvSpPr>
@@ -5975,84 +5897,6 @@
         </p:nvSpPr>
         <p:spPr>
           <a:xfrm>
-            <a:off x="182880" y="1024128"/>
-            <a:ext cx="2487168" cy="1399032"/>
-          </a:xfrm>
-          <a:prstGeom prst="rect">
-            <a:avLst/>
-          </a:prstGeom>
-          <a:solidFill>
-            <a:srgbClr val="D1D5DB"/>
-          </a:solidFill>
-          <a:ln>
-            <a:solidFill>
-              <a:srgbClr val="FFFFFF"/>
-            </a:solidFill>
-          </a:ln>
-        </p:spPr>
-        <p:style>
-          <a:lnRef idx="1">
-            <a:schemeClr val="accent1"/>
-          </a:lnRef>
-          <a:fillRef idx="3">
-            <a:schemeClr val="accent1"/>
-          </a:fillRef>
-          <a:effectRef idx="2">
-            <a:schemeClr val="accent1"/>
-          </a:effectRef>
-          <a:fontRef idx="minor">
-            <a:schemeClr val="lt1"/>
-          </a:fontRef>
-        </p:style>
-        <p:txBody>
-          <a:bodyPr rtlCol="0" anchor="ctr"/>
-          <a:lstStyle/>
-          <a:p>
-            <a:pPr algn="ctr"/>
-          </a:p>
-        </p:txBody>
-      </p:sp>
-      <p:sp>
-        <p:nvSpPr>
-          <p:cNvPr id="7" name="TextBox 6"/>
-          <p:cNvSpPr txBox="1"/>
-          <p:nvPr/>
-        </p:nvSpPr>
-        <p:spPr>
-          <a:xfrm>
-            <a:off x="228600" y="1613916"/>
-            <a:ext cx="2395728" cy="219456"/>
-          </a:xfrm>
-          <a:prstGeom prst="rect">
-            <a:avLst/>
-          </a:prstGeom>
-          <a:noFill/>
-        </p:spPr>
-        <p:txBody>
-          <a:bodyPr wrap="square"/>
-          <a:lstStyle/>
-          <a:p>
-            <a:pPr algn="ctr"/>
-            <a:r>
-              <a:rPr sz="700" b="0" i="0">
-                <a:solidFill>
-                  <a:srgbClr val="64748B"/>
-                </a:solidFill>
-                <a:latin typeface="Calibri"/>
-              </a:rPr>
-              <a:t>Staircase Image</a:t>
-            </a:r>
-          </a:p>
-        </p:txBody>
-      </p:sp>
-      <p:sp>
-        <p:nvSpPr>
-          <p:cNvPr id="8" name="Rectangle 7"/>
-          <p:cNvSpPr/>
-          <p:nvPr/>
-        </p:nvSpPr>
-        <p:spPr>
-          <a:xfrm>
             <a:off x="182880" y="2450592"/>
             <a:ext cx="2487168" cy="18288"/>
           </a:xfrm>
@@ -6092,7 +5936,7 @@
       </p:sp>
       <p:sp>
         <p:nvSpPr>
-          <p:cNvPr id="9" name="TextBox 8"/>
+          <p:cNvPr id="7" name="TextBox 6"/>
           <p:cNvSpPr txBox="1"/>
           <p:nvPr/>
         </p:nvSpPr>
@@ -6125,7 +5969,7 @@
       </p:sp>
       <p:sp>
         <p:nvSpPr>
-          <p:cNvPr id="10" name="TextBox 9"/>
+          <p:cNvPr id="8" name="TextBox 7"/>
           <p:cNvSpPr txBox="1"/>
           <p:nvPr/>
         </p:nvSpPr>
@@ -6151,14 +5995,14 @@
                 </a:solidFill>
                 <a:latin typeface="Calibri"/>
               </a:rPr>
-              <a:t>Lead generation, intake, team, and profit must all work together. Missing any one means growth stalls regardless of ad spend.</a:t>
-            </a:r>
-          </a:p>
-        </p:txBody>
-      </p:sp>
-      <p:sp>
-        <p:nvSpPr>
-          <p:cNvPr id="11" name="Rectangle 10"/>
+              <a:t>All four pillars must work together — miss any one and growth stalls regardless of how talented the attorneys are. When they run as a system, James and Mireya can step back and let the firm grow without them in every room.</a:t>
+            </a:r>
+          </a:p>
+        </p:txBody>
+      </p:sp>
+      <p:sp>
+        <p:nvSpPr>
+          <p:cNvPr id="9" name="Rectangle 8"/>
           <p:cNvSpPr/>
           <p:nvPr/>
         </p:nvSpPr>
@@ -6203,7 +6047,7 @@
       </p:sp>
       <p:sp>
         <p:nvSpPr>
-          <p:cNvPr id="12" name="TextBox 11"/>
+          <p:cNvPr id="10" name="TextBox 9"/>
           <p:cNvSpPr txBox="1"/>
           <p:nvPr/>
         </p:nvSpPr>
@@ -6236,7 +6080,7 @@
       </p:sp>
       <p:sp>
         <p:nvSpPr>
-          <p:cNvPr id="13" name="TextBox 12"/>
+          <p:cNvPr id="11" name="TextBox 10"/>
           <p:cNvSpPr txBox="1"/>
           <p:nvPr/>
         </p:nvSpPr>
@@ -6262,14 +6106,14 @@
                 </a:solidFill>
                 <a:latin typeface="Calibri"/>
               </a:rPr>
-              <a:t>Build a firm that runs itself</a:t>
-            </a:r>
-          </a:p>
-        </p:txBody>
-      </p:sp>
-      <p:sp>
-        <p:nvSpPr>
-          <p:cNvPr id="14" name="Rectangle 13"/>
+              <a:t>Step back and let the firm grow without you</a:t>
+            </a:r>
+          </a:p>
+        </p:txBody>
+      </p:sp>
+      <p:sp>
+        <p:nvSpPr>
+          <p:cNvPr id="12" name="Rectangle 11"/>
           <p:cNvSpPr/>
           <p:nvPr/>
         </p:nvSpPr>
@@ -6314,7 +6158,7 @@
       </p:sp>
       <p:sp>
         <p:nvSpPr>
-          <p:cNvPr id="15" name="TextBox 14"/>
+          <p:cNvPr id="13" name="TextBox 12"/>
           <p:cNvSpPr txBox="1"/>
           <p:nvPr/>
         </p:nvSpPr>
@@ -6347,7 +6191,7 @@
       </p:sp>
       <p:sp>
         <p:nvSpPr>
-          <p:cNvPr id="16" name="TextBox 15"/>
+          <p:cNvPr id="14" name="TextBox 13"/>
           <p:cNvSpPr txBox="1"/>
           <p:nvPr/>
         </p:nvSpPr>
@@ -6380,7 +6224,7 @@
       </p:sp>
       <p:sp>
         <p:nvSpPr>
-          <p:cNvPr id="17" name="TextBox 16"/>
+          <p:cNvPr id="15" name="TextBox 14"/>
           <p:cNvSpPr txBox="1"/>
           <p:nvPr/>
         </p:nvSpPr>
@@ -6413,7 +6257,7 @@
       </p:sp>
       <p:sp>
         <p:nvSpPr>
-          <p:cNvPr id="18" name="Rectangle 17"/>
+          <p:cNvPr id="16" name="Rectangle 15"/>
           <p:cNvSpPr/>
           <p:nvPr/>
         </p:nvSpPr>
@@ -6458,7 +6302,7 @@
       </p:sp>
       <p:sp>
         <p:nvSpPr>
-          <p:cNvPr id="19" name="Rectangle 18"/>
+          <p:cNvPr id="17" name="Rectangle 16"/>
           <p:cNvSpPr/>
           <p:nvPr/>
         </p:nvSpPr>
@@ -6503,7 +6347,7 @@
       </p:sp>
       <p:sp>
         <p:nvSpPr>
-          <p:cNvPr id="20" name="TextBox 19"/>
+          <p:cNvPr id="18" name="TextBox 17"/>
           <p:cNvSpPr txBox="1"/>
           <p:nvPr/>
         </p:nvSpPr>
@@ -6529,14 +6373,14 @@
                 </a:solidFill>
                 <a:latin typeface="Calibri"/>
               </a:rPr>
-              <a:t>Launch Google Ads for estate planning keywords</a:t>
-            </a:r>
-          </a:p>
-        </p:txBody>
-      </p:sp>
-      <p:sp>
-        <p:nvSpPr>
-          <p:cNvPr id="21" name="Rectangle 20"/>
+              <a:t>Google LSA — qualified leads call you directly</a:t>
+            </a:r>
+          </a:p>
+        </p:txBody>
+      </p:sp>
+      <p:sp>
+        <p:nvSpPr>
+          <p:cNvPr id="19" name="Rectangle 18"/>
           <p:cNvSpPr/>
           <p:nvPr/>
         </p:nvSpPr>
@@ -6581,7 +6425,7 @@
       </p:sp>
       <p:sp>
         <p:nvSpPr>
-          <p:cNvPr id="22" name="Rectangle 21"/>
+          <p:cNvPr id="20" name="Rectangle 19"/>
           <p:cNvSpPr/>
           <p:nvPr/>
         </p:nvSpPr>
@@ -6626,7 +6470,7 @@
       </p:sp>
       <p:sp>
         <p:nvSpPr>
-          <p:cNvPr id="23" name="TextBox 22"/>
+          <p:cNvPr id="21" name="TextBox 20"/>
           <p:cNvSpPr txBox="1"/>
           <p:nvPr/>
         </p:nvSpPr>
@@ -6652,14 +6496,14 @@
                 </a:solidFill>
                 <a:latin typeface="Calibri"/>
               </a:rPr>
-              <a:t>Activate LSA — pay per call, not per click</a:t>
-            </a:r>
-          </a:p>
-        </p:txBody>
-      </p:sp>
-      <p:sp>
-        <p:nvSpPr>
-          <p:cNvPr id="24" name="Rectangle 23"/>
+              <a:t>Spanish ads — a channel no competitor can match</a:t>
+            </a:r>
+          </a:p>
+        </p:txBody>
+      </p:sp>
+      <p:sp>
+        <p:nvSpPr>
+          <p:cNvPr id="22" name="Rectangle 21"/>
           <p:cNvSpPr/>
           <p:nvPr/>
         </p:nvSpPr>
@@ -6704,7 +6548,7 @@
       </p:sp>
       <p:sp>
         <p:nvSpPr>
-          <p:cNvPr id="25" name="Rectangle 24"/>
+          <p:cNvPr id="23" name="Rectangle 22"/>
           <p:cNvSpPr/>
           <p:nvPr/>
         </p:nvSpPr>
@@ -6749,7 +6593,7 @@
       </p:sp>
       <p:sp>
         <p:nvSpPr>
-          <p:cNvPr id="26" name="TextBox 25"/>
+          <p:cNvPr id="24" name="TextBox 23"/>
           <p:cNvSpPr txBox="1"/>
           <p:nvPr/>
         </p:nvSpPr>
@@ -6775,14 +6619,14 @@
                 </a:solidFill>
                 <a:latin typeface="Calibri"/>
               </a:rPr>
-              <a:t>Launch Spanish-language ad campaigns</a:t>
-            </a:r>
-          </a:p>
-        </p:txBody>
-      </p:sp>
-      <p:sp>
-        <p:nvSpPr>
-          <p:cNvPr id="27" name="Rectangle 26"/>
+              <a:t>Contact form above fold — convert existing traffic</a:t>
+            </a:r>
+          </a:p>
+        </p:txBody>
+      </p:sp>
+      <p:sp>
+        <p:nvSpPr>
+          <p:cNvPr id="25" name="Rectangle 24"/>
           <p:cNvSpPr/>
           <p:nvPr/>
         </p:nvSpPr>
@@ -6827,7 +6671,7 @@
       </p:sp>
       <p:sp>
         <p:nvSpPr>
-          <p:cNvPr id="28" name="Rectangle 27"/>
+          <p:cNvPr id="26" name="Rectangle 25"/>
           <p:cNvSpPr/>
           <p:nvPr/>
         </p:nvSpPr>
@@ -6872,7 +6716,7 @@
       </p:sp>
       <p:sp>
         <p:nvSpPr>
-          <p:cNvPr id="29" name="TextBox 28"/>
+          <p:cNvPr id="27" name="TextBox 26"/>
           <p:cNvSpPr txBox="1"/>
           <p:nvPr/>
         </p:nvSpPr>
@@ -6898,14 +6742,14 @@
                 </a:solidFill>
                 <a:latin typeface="Calibri"/>
               </a:rPr>
-              <a:t>Build geo pages for Spring, Conroe, Tomball</a:t>
-            </a:r>
-          </a:p>
-        </p:txBody>
-      </p:sp>
-      <p:sp>
-        <p:nvSpPr>
-          <p:cNvPr id="30" name="Rectangle 29"/>
+              <a:t>Geo pages for Spring, Conroe — widen your market</a:t>
+            </a:r>
+          </a:p>
+        </p:txBody>
+      </p:sp>
+      <p:sp>
+        <p:nvSpPr>
+          <p:cNvPr id="28" name="Rectangle 27"/>
           <p:cNvSpPr/>
           <p:nvPr/>
         </p:nvSpPr>
@@ -6950,7 +6794,7 @@
       </p:sp>
       <p:sp>
         <p:nvSpPr>
-          <p:cNvPr id="31" name="Rectangle 30"/>
+          <p:cNvPr id="29" name="Rectangle 28"/>
           <p:cNvSpPr/>
           <p:nvPr/>
         </p:nvSpPr>
@@ -6995,7 +6839,7 @@
       </p:sp>
       <p:sp>
         <p:nvSpPr>
-          <p:cNvPr id="32" name="TextBox 31"/>
+          <p:cNvPr id="30" name="TextBox 29"/>
           <p:cNvSpPr txBox="1"/>
           <p:nvPr/>
         </p:nvSpPr>
@@ -7021,14 +6865,14 @@
                 </a:solidFill>
                 <a:latin typeface="Calibri"/>
               </a:rPr>
-              <a:t>Optimize GBP for local 3-pack ranking</a:t>
-            </a:r>
-          </a:p>
-        </p:txBody>
-      </p:sp>
-      <p:sp>
-        <p:nvSpPr>
-          <p:cNvPr id="33" name="Rectangle 32"/>
+              <a:t>32 five-star reviews → Google Screened visibility</a:t>
+            </a:r>
+          </a:p>
+        </p:txBody>
+      </p:sp>
+      <p:sp>
+        <p:nvSpPr>
+          <p:cNvPr id="31" name="Rectangle 30"/>
           <p:cNvSpPr/>
           <p:nvPr/>
         </p:nvSpPr>
@@ -7073,7 +6917,7 @@
       </p:sp>
       <p:sp>
         <p:nvSpPr>
-          <p:cNvPr id="34" name="TextBox 33"/>
+          <p:cNvPr id="32" name="TextBox 31"/>
           <p:cNvSpPr txBox="1"/>
           <p:nvPr/>
         </p:nvSpPr>
@@ -7106,7 +6950,7 @@
       </p:sp>
       <p:sp>
         <p:nvSpPr>
-          <p:cNvPr id="35" name="TextBox 34"/>
+          <p:cNvPr id="33" name="TextBox 32"/>
           <p:cNvSpPr txBox="1"/>
           <p:nvPr/>
         </p:nvSpPr>
@@ -7139,7 +6983,7 @@
       </p:sp>
       <p:sp>
         <p:nvSpPr>
-          <p:cNvPr id="36" name="TextBox 35"/>
+          <p:cNvPr id="34" name="TextBox 33"/>
           <p:cNvSpPr txBox="1"/>
           <p:nvPr/>
         </p:nvSpPr>
@@ -7172,7 +7016,7 @@
       </p:sp>
       <p:sp>
         <p:nvSpPr>
-          <p:cNvPr id="37" name="Rectangle 36"/>
+          <p:cNvPr id="35" name="Rectangle 34"/>
           <p:cNvSpPr/>
           <p:nvPr/>
         </p:nvSpPr>
@@ -7217,7 +7061,7 @@
       </p:sp>
       <p:sp>
         <p:nvSpPr>
-          <p:cNvPr id="38" name="Rectangle 37"/>
+          <p:cNvPr id="36" name="Rectangle 35"/>
           <p:cNvSpPr/>
           <p:nvPr/>
         </p:nvSpPr>
@@ -7262,7 +7106,7 @@
       </p:sp>
       <p:sp>
         <p:nvSpPr>
-          <p:cNvPr id="39" name="TextBox 38"/>
+          <p:cNvPr id="37" name="TextBox 36"/>
           <p:cNvSpPr txBox="1"/>
           <p:nvPr/>
         </p:nvSpPr>
@@ -7288,14 +7132,14 @@
                 </a:solidFill>
                 <a:latin typeface="Calibri"/>
               </a:rPr>
-              <a:t>Add after-hours intake mechanism</a:t>
-            </a:r>
-          </a:p>
-        </p:txBody>
-      </p:sp>
-      <p:sp>
-        <p:nvSpPr>
-          <p:cNvPr id="40" name="Rectangle 39"/>
+              <a:t>After-hours intake — no evening call goes unanswered</a:t>
+            </a:r>
+          </a:p>
+        </p:txBody>
+      </p:sp>
+      <p:sp>
+        <p:nvSpPr>
+          <p:cNvPr id="38" name="Rectangle 37"/>
           <p:cNvSpPr/>
           <p:nvPr/>
         </p:nvSpPr>
@@ -7340,7 +7184,7 @@
       </p:sp>
       <p:sp>
         <p:nvSpPr>
-          <p:cNvPr id="41" name="Rectangle 40"/>
+          <p:cNvPr id="39" name="Rectangle 38"/>
           <p:cNvSpPr/>
           <p:nvPr/>
         </p:nvSpPr>
@@ -7385,7 +7229,7 @@
       </p:sp>
       <p:sp>
         <p:nvSpPr>
-          <p:cNvPr id="42" name="TextBox 41"/>
+          <p:cNvPr id="40" name="TextBox 39"/>
           <p:cNvSpPr txBox="1"/>
           <p:nvPr/>
         </p:nvSpPr>
@@ -7411,14 +7255,14 @@
                 </a:solidFill>
                 <a:latin typeface="Calibri"/>
               </a:rPr>
-              <a:t>Move contact form above the fold</a:t>
-            </a:r>
-          </a:p>
-        </p:txBody>
-      </p:sp>
-      <p:sp>
-        <p:nvSpPr>
-          <p:cNvPr id="43" name="Rectangle 42"/>
+              <a:t>3-step follow-up sequence — stop losing warm leads</a:t>
+            </a:r>
+          </a:p>
+        </p:txBody>
+      </p:sp>
+      <p:sp>
+        <p:nvSpPr>
+          <p:cNvPr id="41" name="Rectangle 40"/>
           <p:cNvSpPr/>
           <p:nvPr/>
         </p:nvSpPr>
@@ -7463,7 +7307,7 @@
       </p:sp>
       <p:sp>
         <p:nvSpPr>
-          <p:cNvPr id="44" name="Rectangle 43"/>
+          <p:cNvPr id="42" name="Rectangle 41"/>
           <p:cNvSpPr/>
           <p:nvPr/>
         </p:nvSpPr>
@@ -7508,7 +7352,7 @@
       </p:sp>
       <p:sp>
         <p:nvSpPr>
-          <p:cNvPr id="45" name="TextBox 44"/>
+          <p:cNvPr id="43" name="TextBox 42"/>
           <p:cNvSpPr txBox="1"/>
           <p:nvPr/>
         </p:nvSpPr>
@@ -7534,14 +7378,14 @@
                 </a:solidFill>
                 <a:latin typeface="Calibri"/>
               </a:rPr>
-              <a:t>Add embedded scheduling widget to site</a:t>
-            </a:r>
-          </a:p>
-        </p:txBody>
-      </p:sp>
-      <p:sp>
-        <p:nvSpPr>
-          <p:cNvPr id="46" name="Rectangle 45"/>
+              <a:t>Booking widget converts visitors before they scroll</a:t>
+            </a:r>
+          </a:p>
+        </p:txBody>
+      </p:sp>
+      <p:sp>
+        <p:nvSpPr>
+          <p:cNvPr id="44" name="Rectangle 43"/>
           <p:cNvSpPr/>
           <p:nvPr/>
         </p:nvSpPr>
@@ -7586,7 +7430,7 @@
       </p:sp>
       <p:sp>
         <p:nvSpPr>
-          <p:cNvPr id="47" name="Rectangle 46"/>
+          <p:cNvPr id="45" name="Rectangle 44"/>
           <p:cNvSpPr/>
           <p:nvPr/>
         </p:nvSpPr>
@@ -7631,7 +7475,7 @@
       </p:sp>
       <p:sp>
         <p:nvSpPr>
-          <p:cNvPr id="48" name="TextBox 47"/>
+          <p:cNvPr id="46" name="TextBox 45"/>
           <p:cNvSpPr txBox="1"/>
           <p:nvPr/>
         </p:nvSpPr>
@@ -7657,14 +7501,14 @@
                 </a:solidFill>
                 <a:latin typeface="Calibri"/>
               </a:rPr>
-              <a:t>Build 3-step follow-up sequence</a:t>
-            </a:r>
-          </a:p>
-        </p:txBody>
-      </p:sp>
-      <p:sp>
-        <p:nvSpPr>
-          <p:cNvPr id="49" name="Rectangle 48"/>
+              <a:t>Track consult-to-client rate weekly — find the leak</a:t>
+            </a:r>
+          </a:p>
+        </p:txBody>
+      </p:sp>
+      <p:sp>
+        <p:nvSpPr>
+          <p:cNvPr id="47" name="Rectangle 46"/>
           <p:cNvSpPr/>
           <p:nvPr/>
         </p:nvSpPr>
@@ -7709,7 +7553,7 @@
       </p:sp>
       <p:sp>
         <p:nvSpPr>
-          <p:cNvPr id="50" name="Rectangle 49"/>
+          <p:cNvPr id="48" name="Rectangle 47"/>
           <p:cNvSpPr/>
           <p:nvPr/>
         </p:nvSpPr>
@@ -7754,7 +7598,7 @@
       </p:sp>
       <p:sp>
         <p:nvSpPr>
-          <p:cNvPr id="51" name="TextBox 50"/>
+          <p:cNvPr id="49" name="TextBox 48"/>
           <p:cNvSpPr txBox="1"/>
           <p:nvPr/>
         </p:nvSpPr>
@@ -7780,14 +7624,14 @@
                 </a:solidFill>
                 <a:latin typeface="Calibri"/>
               </a:rPr>
-              <a:t>Track inquiry volume and conversion rate</a:t>
-            </a:r>
-          </a:p>
-        </p:txBody>
-      </p:sp>
-      <p:sp>
-        <p:nvSpPr>
-          <p:cNvPr id="52" name="Rectangle 51"/>
+              <a:t>Structured intake script — faster, consistent process</a:t>
+            </a:r>
+          </a:p>
+        </p:txBody>
+      </p:sp>
+      <p:sp>
+        <p:nvSpPr>
+          <p:cNvPr id="50" name="Rectangle 49"/>
           <p:cNvSpPr/>
           <p:nvPr/>
         </p:nvSpPr>
@@ -7832,7 +7676,7 @@
       </p:sp>
       <p:sp>
         <p:nvSpPr>
-          <p:cNvPr id="53" name="TextBox 52"/>
+          <p:cNvPr id="51" name="TextBox 50"/>
           <p:cNvSpPr txBox="1"/>
           <p:nvPr/>
         </p:nvSpPr>
@@ -7865,7 +7709,7 @@
       </p:sp>
       <p:sp>
         <p:nvSpPr>
-          <p:cNvPr id="54" name="TextBox 53"/>
+          <p:cNvPr id="52" name="TextBox 51"/>
           <p:cNvSpPr txBox="1"/>
           <p:nvPr/>
         </p:nvSpPr>
@@ -7898,7 +7742,7 @@
       </p:sp>
       <p:sp>
         <p:nvSpPr>
-          <p:cNvPr id="55" name="TextBox 54"/>
+          <p:cNvPr id="53" name="TextBox 52"/>
           <p:cNvSpPr txBox="1"/>
           <p:nvPr/>
         </p:nvSpPr>
@@ -7931,7 +7775,7 @@
       </p:sp>
       <p:sp>
         <p:nvSpPr>
-          <p:cNvPr id="56" name="Rectangle 55"/>
+          <p:cNvPr id="54" name="Rectangle 53"/>
           <p:cNvSpPr/>
           <p:nvPr/>
         </p:nvSpPr>
@@ -7976,7 +7820,7 @@
       </p:sp>
       <p:sp>
         <p:nvSpPr>
-          <p:cNvPr id="57" name="Rectangle 56"/>
+          <p:cNvPr id="55" name="Rectangle 54"/>
           <p:cNvSpPr/>
           <p:nvPr/>
         </p:nvSpPr>
@@ -8021,7 +7865,7 @@
       </p:sp>
       <p:sp>
         <p:nvSpPr>
-          <p:cNvPr id="58" name="TextBox 57"/>
+          <p:cNvPr id="56" name="TextBox 55"/>
           <p:cNvSpPr txBox="1"/>
           <p:nvPr/>
         </p:nvSpPr>
@@ -8047,14 +7891,14 @@
                 </a:solidFill>
                 <a:latin typeface="Calibri"/>
               </a:rPr>
-              <a:t>Document intake &amp; onboarding SOPs first</a:t>
-            </a:r>
-          </a:p>
-        </p:txBody>
-      </p:sp>
-      <p:sp>
-        <p:nvSpPr>
-          <p:cNvPr id="59" name="Rectangle 58"/>
+              <a:t>Document SOPs before hiring — scale without chaos</a:t>
+            </a:r>
+          </a:p>
+        </p:txBody>
+      </p:sp>
+      <p:sp>
+        <p:nvSpPr>
+          <p:cNvPr id="57" name="Rectangle 56"/>
           <p:cNvSpPr/>
           <p:nvPr/>
         </p:nvSpPr>
@@ -8099,7 +7943,7 @@
       </p:sp>
       <p:sp>
         <p:nvSpPr>
-          <p:cNvPr id="60" name="Rectangle 59"/>
+          <p:cNvPr id="58" name="Rectangle 57"/>
           <p:cNvSpPr/>
           <p:nvPr/>
         </p:nvSpPr>
@@ -8144,7 +7988,7 @@
       </p:sp>
       <p:sp>
         <p:nvSpPr>
-          <p:cNvPr id="61" name="TextBox 60"/>
+          <p:cNvPr id="59" name="TextBox 58"/>
           <p:cNvSpPr txBox="1"/>
           <p:nvPr/>
         </p:nvSpPr>
@@ -8170,14 +8014,14 @@
                 </a:solidFill>
                 <a:latin typeface="Calibri"/>
               </a:rPr>
-              <a:t>Hire first support staff with systems ready</a:t>
-            </a:r>
-          </a:p>
-        </p:txBody>
-      </p:sp>
-      <p:sp>
-        <p:nvSpPr>
-          <p:cNvPr id="62" name="Rectangle 61"/>
+              <a:t>Track revenue by practice area — know best margins</a:t>
+            </a:r>
+          </a:p>
+        </p:txBody>
+      </p:sp>
+      <p:sp>
+        <p:nvSpPr>
+          <p:cNvPr id="60" name="Rectangle 59"/>
           <p:cNvSpPr/>
           <p:nvPr/>
         </p:nvSpPr>
@@ -8222,7 +8066,7 @@
       </p:sp>
       <p:sp>
         <p:nvSpPr>
-          <p:cNvPr id="63" name="Rectangle 62"/>
+          <p:cNvPr id="61" name="Rectangle 60"/>
           <p:cNvSpPr/>
           <p:nvPr/>
         </p:nvSpPr>
@@ -8267,7 +8111,7 @@
       </p:sp>
       <p:sp>
         <p:nvSpPr>
-          <p:cNvPr id="64" name="TextBox 63"/>
+          <p:cNvPr id="62" name="TextBox 61"/>
           <p:cNvSpPr txBox="1"/>
           <p:nvPr/>
         </p:nvSpPr>
@@ -8293,14 +8137,14 @@
                 </a:solidFill>
                 <a:latin typeface="Calibri"/>
               </a:rPr>
-              <a:t>Track revenue by practice area monthly</a:t>
-            </a:r>
-          </a:p>
-        </p:txBody>
-      </p:sp>
-      <p:sp>
-        <p:nvSpPr>
-          <p:cNvPr id="65" name="Rectangle 64"/>
+              <a:t>First support hire with training system in place</a:t>
+            </a:r>
+          </a:p>
+        </p:txBody>
+      </p:sp>
+      <p:sp>
+        <p:nvSpPr>
+          <p:cNvPr id="63" name="Rectangle 62"/>
           <p:cNvSpPr/>
           <p:nvPr/>
         </p:nvSpPr>
@@ -8345,7 +8189,7 @@
       </p:sp>
       <p:sp>
         <p:nvSpPr>
-          <p:cNvPr id="66" name="Rectangle 65"/>
+          <p:cNvPr id="64" name="Rectangle 63"/>
           <p:cNvSpPr/>
           <p:nvPr/>
         </p:nvSpPr>
@@ -8390,7 +8234,7 @@
       </p:sp>
       <p:sp>
         <p:nvSpPr>
-          <p:cNvPr id="67" name="TextBox 66"/>
+          <p:cNvPr id="65" name="TextBox 64"/>
           <p:cNvSpPr txBox="1"/>
           <p:nvPr/>
         </p:nvSpPr>
@@ -8416,14 +8260,14 @@
                 </a:solidFill>
                 <a:latin typeface="Calibri"/>
               </a:rPr>
-              <a:t>Establish owner compensation plan</a:t>
-            </a:r>
-          </a:p>
-        </p:txBody>
-      </p:sp>
-      <p:sp>
-        <p:nvSpPr>
-          <p:cNvPr id="68" name="Rectangle 67"/>
+              <a:t>Monthly profit review — more revenue you actually keep</a:t>
+            </a:r>
+          </a:p>
+        </p:txBody>
+      </p:sp>
+      <p:sp>
+        <p:nvSpPr>
+          <p:cNvPr id="66" name="Rectangle 65"/>
           <p:cNvSpPr/>
           <p:nvPr/>
         </p:nvSpPr>
@@ -8468,7 +8312,7 @@
       </p:sp>
       <p:sp>
         <p:nvSpPr>
-          <p:cNvPr id="69" name="Rectangle 68"/>
+          <p:cNvPr id="67" name="Rectangle 66"/>
           <p:cNvSpPr/>
           <p:nvPr/>
         </p:nvSpPr>
@@ -8513,7 +8357,7 @@
       </p:sp>
       <p:sp>
         <p:nvSpPr>
-          <p:cNvPr id="70" name="TextBox 69"/>
+          <p:cNvPr id="68" name="TextBox 67"/>
           <p:cNvSpPr txBox="1"/>
           <p:nvPr/>
         </p:nvSpPr>
@@ -8539,14 +8383,14 @@
                 </a:solidFill>
                 <a:latin typeface="Calibri"/>
               </a:rPr>
-              <a:t>Build review request sequence — target 50+</a:t>
-            </a:r>
-          </a:p>
-        </p:txBody>
-      </p:sp>
-      <p:sp>
-        <p:nvSpPr>
-          <p:cNvPr id="71" name="Rectangle 70"/>
+              <a:t>A firm that runs systems, not one that runs on you</a:t>
+            </a:r>
+          </a:p>
+        </p:txBody>
+      </p:sp>
+      <p:sp>
+        <p:nvSpPr>
+          <p:cNvPr id="69" name="Rectangle 68"/>
           <p:cNvSpPr/>
           <p:nvPr/>
         </p:nvSpPr>
@@ -8591,7 +8435,7 @@
       </p:sp>
       <p:pic>
         <p:nvPicPr>
-          <p:cNvPr id="72" name="Picture 71" descr="smb_team_logo.png"/>
+          <p:cNvPr id="70" name="Picture 69" descr="smb_team_logo.png"/>
           <p:cNvPicPr>
             <a:picLocks noChangeAspect="1"/>
           </p:cNvPicPr>
@@ -8615,7 +8459,7 @@
       </p:pic>
       <p:sp>
         <p:nvSpPr>
-          <p:cNvPr id="73" name="TextBox 72"/>
+          <p:cNvPr id="71" name="TextBox 70"/>
           <p:cNvSpPr txBox="1"/>
           <p:nvPr/>
         </p:nvSpPr>
@@ -8648,7 +8492,7 @@
       </p:sp>
       <p:sp>
         <p:nvSpPr>
-          <p:cNvPr id="74" name="TextBox 73"/>
+          <p:cNvPr id="72" name="TextBox 71"/>
           <p:cNvSpPr txBox="1"/>
           <p:nvPr/>
         </p:nvSpPr>
@@ -9021,7 +8865,7 @@
             <a:r>
               <a:rPr sz="1100" b="0" i="0">
                 <a:solidFill>
-                  <a:srgbClr val="64748B"/>
+                  <a:srgbClr val="334155"/>
                 </a:solidFill>
                 <a:latin typeface="Calibri"/>
               </a:rPr>
@@ -9045,7 +8889,7 @@
             <a:avLst/>
           </a:prstGeom>
           <a:solidFill>
-            <a:srgbClr val="64748B"/>
+            <a:srgbClr val="334155"/>
           </a:solidFill>
           <a:ln>
             <a:solidFill>
@@ -9103,7 +8947,7 @@
                 </a:solidFill>
                 <a:latin typeface="Calibri"/>
               </a:rPr>
-              <a:t>Google Ads · LSA · SEO · GBP · Website Optimization</a:t>
+              <a:t>Google Ads · LSA · SEO · GBP · Website optimization</a:t>
             </a:r>
           </a:p>
         </p:txBody>
@@ -9321,7 +9165,7 @@
             <a:r>
               <a:rPr sz="1100" b="0" i="0">
                 <a:solidFill>
-                  <a:srgbClr val="64748B"/>
+                  <a:srgbClr val="334155"/>
                 </a:solidFill>
                 <a:latin typeface="Calibri"/>
               </a:rPr>
@@ -9345,7 +9189,7 @@
             <a:avLst/>
           </a:prstGeom>
           <a:solidFill>
-            <a:srgbClr val="64748B"/>
+            <a:srgbClr val="334155"/>
           </a:solidFill>
           <a:ln>
             <a:solidFill>
@@ -9403,7 +9247,7 @@
                 </a:solidFill>
                 <a:latin typeface="Calibri"/>
               </a:rPr>
-              <a:t>1-on-1 coaching · Masterminds · Group sessions</a:t>
+              <a:t>Weekly coaching · KPI scorecards · Intake framework</a:t>
             </a:r>
           </a:p>
         </p:txBody>
@@ -9769,7 +9613,7 @@
                 </a:solidFill>
                 <a:latin typeface="Calibri"/>
               </a:rPr>
-              <a:t>$3,500 (est.)</a:t>
+              <a:t>$3,500</a:t>
             </a:r>
           </a:p>
         </p:txBody>
@@ -9880,7 +9724,7 @@
                 </a:solidFill>
                 <a:latin typeface="Calibri"/>
               </a:rPr>
-              <a:t>$21,000 revenue · 3.8x ROAS</a:t>
+              <a:t>$21,000 revenue · 3.8× ROAS</a:t>
             </a:r>
           </a:p>
         </p:txBody>
@@ -9946,7 +9790,7 @@
                 </a:solidFill>
                 <a:latin typeface="Calibri"/>
               </a:rPr>
-              <a:t>$91,000 revenue · 6.1x ROAS</a:t>
+              <a:t>$91,000 revenue · 6.1× ROAS</a:t>
             </a:r>
           </a:p>
         </p:txBody>
@@ -10090,7 +9934,7 @@
                 </a:solidFill>
                 <a:latin typeface="Calibri"/>
               </a:rPr>
-              <a:t>Google Ads &amp; LSA campaigns go live</a:t>
+              <a:t>Launch Google Ads and LSA — paid leads active</a:t>
             </a:r>
           </a:p>
         </p:txBody>
@@ -10201,7 +10045,7 @@
                 </a:solidFill>
                 <a:latin typeface="Calibri"/>
               </a:rPr>
-              <a:t>Website conversion optimization complete</a:t>
+              <a:t>Contact form above fold, booking widget live</a:t>
             </a:r>
           </a:p>
         </p:txBody>
@@ -10312,7 +10156,7 @@
                 </a:solidFill>
                 <a:latin typeface="Calibri"/>
               </a:rPr>
-              <a:t>Coaching kickoff — metrics &amp; 90-day plan</a:t>
+              <a:t>Coaching kickoff — baseline metrics and 90-day plan</a:t>
             </a:r>
           </a:p>
         </p:txBody>
@@ -10423,7 +10267,7 @@
                 </a:solidFill>
                 <a:latin typeface="Calibri"/>
               </a:rPr>
-              <a:t>Geo landing pages for Spring &amp; Conroe built</a:t>
+              <a:t>Geo landing pages for Spring and Conroe TX</a:t>
             </a:r>
           </a:p>
         </p:txBody>
@@ -10534,7 +10378,7 @@
                 </a:solidFill>
                 <a:latin typeface="Calibri"/>
               </a:rPr>
-              <a:t>Review sequence active — targeting 50+ reviews</a:t>
+              <a:t>Automated review sequence live — targeting 50+ reviews</a:t>
             </a:r>
           </a:p>
         </p:txBody>
@@ -10612,7 +10456,7 @@
                 </a:solidFill>
                 <a:latin typeface="Calibri"/>
               </a:rPr>
-              <a:t>"The Woodlands market is contested, not conquered — a bilingual firm with five-star reviews wins when it builds the systems to be found."</a:t>
+              <a:t>"You did not start this firm to handle every intake call yourself. You started it to help families — and to build something that works without requiring everything from both of you."</a:t>
             </a:r>
           </a:p>
         </p:txBody>

</xml_diff>

<commit_message>
Remove staircase from PPTX template; add banner to Slide 1; tighten layout
- Slide 1: replaced loose yellow-strip header with full-width NAVY banner
  matching slides 2 and 3; right panel now starts at y=1.05 (below banner);
  YOU ARE HERE strip moved up to y=1.12; competitor table shifted up to fill
  the space previously occupied by the website screenshot
- Slide 2: removed staircase image entirely (Dropbox CDN blocked in CI);
  SMB Team Model section moved up to top of left panel with more description
  space; GOAL card repositioned to y=3.28
- audit-pptx.md: removed STAIRCASE_STAGE instruction
- Dickey Law Group proposal regenerated with updated layout

https://claude.ai/code/session_013MDLDGdmxxHB21zUAgdWp5
</commit_message>
<xml_diff>
--- a/dickey-law-group/Dickey_Law_Group_May_18_2026_Proposal.pptx
+++ b/dickey-law-group/Dickey_Law_Group_May_18_2026_Proposal.pptx
@@ -3099,7 +3099,118 @@
         <p:spPr>
           <a:xfrm>
             <a:off x="0" y="0"/>
-            <a:ext cx="146304" cy="5143500"/>
+            <a:ext cx="9144000" cy="960120"/>
+          </a:xfrm>
+          <a:prstGeom prst="rect">
+            <a:avLst/>
+          </a:prstGeom>
+          <a:solidFill>
+            <a:srgbClr val="0D1F3C"/>
+          </a:solidFill>
+          <a:ln>
+            <a:solidFill>
+              <a:srgbClr val="FFFFFF"/>
+            </a:solidFill>
+          </a:ln>
+        </p:spPr>
+        <p:style>
+          <a:lnRef idx="1">
+            <a:schemeClr val="accent1"/>
+          </a:lnRef>
+          <a:fillRef idx="3">
+            <a:schemeClr val="accent1"/>
+          </a:fillRef>
+          <a:effectRef idx="2">
+            <a:schemeClr val="accent1"/>
+          </a:effectRef>
+          <a:fontRef idx="minor">
+            <a:schemeClr val="lt1"/>
+          </a:fontRef>
+        </p:style>
+        <p:txBody>
+          <a:bodyPr rtlCol="0" anchor="ctr"/>
+          <a:lstStyle/>
+          <a:p>
+            <a:pPr algn="ctr"/>
+          </a:p>
+        </p:txBody>
+      </p:sp>
+      <p:sp>
+        <p:nvSpPr>
+          <p:cNvPr id="3" name="TextBox 2"/>
+          <p:cNvSpPr txBox="1"/>
+          <p:nvPr/>
+        </p:nvSpPr>
+        <p:spPr>
+          <a:xfrm>
+            <a:off x="292608" y="91440"/>
+            <a:ext cx="8595360" cy="201168"/>
+          </a:xfrm>
+          <a:prstGeom prst="rect">
+            <a:avLst/>
+          </a:prstGeom>
+          <a:noFill/>
+        </p:spPr>
+        <p:txBody>
+          <a:bodyPr wrap="square"/>
+          <a:lstStyle/>
+          <a:p>
+            <a:pPr algn="l"/>
+            <a:r>
+              <a:rPr sz="800" b="1" i="0">
+                <a:solidFill>
+                  <a:srgbClr val="F5C400"/>
+                </a:solidFill>
+                <a:latin typeface="Calibri"/>
+              </a:rPr>
+              <a:t>LAW FIRM GROWTH AUDIT  ·  DICKEY LAW GROUP PLLC</a:t>
+            </a:r>
+          </a:p>
+        </p:txBody>
+      </p:sp>
+      <p:sp>
+        <p:nvSpPr>
+          <p:cNvPr id="4" name="TextBox 3"/>
+          <p:cNvSpPr txBox="1"/>
+          <p:nvPr/>
+        </p:nvSpPr>
+        <p:spPr>
+          <a:xfrm>
+            <a:off x="292608" y="310896"/>
+            <a:ext cx="8595360" cy="548640"/>
+          </a:xfrm>
+          <a:prstGeom prst="rect">
+            <a:avLst/>
+          </a:prstGeom>
+          <a:noFill/>
+        </p:spPr>
+        <p:txBody>
+          <a:bodyPr wrap="square"/>
+          <a:lstStyle/>
+          <a:p>
+            <a:pPr algn="l"/>
+            <a:r>
+              <a:rPr sz="2400" b="1" i="0">
+                <a:solidFill>
+                  <a:srgbClr val="FFFFFF"/>
+                </a:solidFill>
+                <a:latin typeface="Calibri"/>
+              </a:rPr>
+              <a:t>Where Dickey Law Group PLLC Stands Today</a:t>
+            </a:r>
+          </a:p>
+        </p:txBody>
+      </p:sp>
+      <p:sp>
+        <p:nvSpPr>
+          <p:cNvPr id="5" name="Rectangle 4"/>
+          <p:cNvSpPr/>
+          <p:nvPr/>
+        </p:nvSpPr>
+        <p:spPr>
+          <a:xfrm>
+            <a:off x="0" y="960120"/>
+            <a:ext cx="146304" cy="3867912"/>
           </a:xfrm>
           <a:prstGeom prst="rect">
             <a:avLst/>
@@ -3137,73 +3248,7 @@
       </p:sp>
       <p:sp>
         <p:nvSpPr>
-          <p:cNvPr id="3" name="TextBox 2"/>
-          <p:cNvSpPr txBox="1"/>
-          <p:nvPr/>
-        </p:nvSpPr>
-        <p:spPr>
-          <a:xfrm>
-            <a:off x="256032" y="155448"/>
-            <a:ext cx="4754880" cy="201168"/>
-          </a:xfrm>
-          <a:prstGeom prst="rect">
-            <a:avLst/>
-          </a:prstGeom>
-          <a:noFill/>
-        </p:spPr>
-        <p:txBody>
-          <a:bodyPr wrap="square"/>
-          <a:lstStyle/>
-          <a:p>
-            <a:pPr algn="l"/>
-            <a:r>
-              <a:rPr sz="800" b="1" i="0">
-                <a:solidFill>
-                  <a:srgbClr val="F5C400"/>
-                </a:solidFill>
-                <a:latin typeface="Calibri"/>
-              </a:rPr>
-              <a:t>LAW FIRM GROWTH AUDIT  ·  DICKEY LAW GROUP PLLC</a:t>
-            </a:r>
-          </a:p>
-        </p:txBody>
-      </p:sp>
-      <p:sp>
-        <p:nvSpPr>
-          <p:cNvPr id="4" name="TextBox 3"/>
-          <p:cNvSpPr txBox="1"/>
-          <p:nvPr/>
-        </p:nvSpPr>
-        <p:spPr>
-          <a:xfrm>
-            <a:off x="256032" y="384048"/>
-            <a:ext cx="4846320" cy="530352"/>
-          </a:xfrm>
-          <a:prstGeom prst="rect">
-            <a:avLst/>
-          </a:prstGeom>
-          <a:noFill/>
-        </p:spPr>
-        <p:txBody>
-          <a:bodyPr wrap="square"/>
-          <a:lstStyle/>
-          <a:p>
-            <a:pPr algn="l"/>
-            <a:r>
-              <a:rPr sz="2400" b="1" i="0">
-                <a:solidFill>
-                  <a:srgbClr val="FFFFFF"/>
-                </a:solidFill>
-                <a:latin typeface="Calibri"/>
-              </a:rPr>
-              <a:t>Where Dickey Law Group PLLC Stands Today</a:t>
-            </a:r>
-          </a:p>
-        </p:txBody>
-      </p:sp>
-      <p:sp>
-        <p:nvSpPr>
-          <p:cNvPr id="5" name="Rectangle 4"/>
+          <p:cNvPr id="6" name="Rectangle 5"/>
           <p:cNvSpPr/>
           <p:nvPr/>
         </p:nvSpPr>
@@ -3248,7 +3293,7 @@
       </p:sp>
       <p:sp>
         <p:nvSpPr>
-          <p:cNvPr id="6" name="TextBox 5"/>
+          <p:cNvPr id="7" name="TextBox 6"/>
           <p:cNvSpPr txBox="1"/>
           <p:nvPr/>
         </p:nvSpPr>
@@ -3281,7 +3326,7 @@
       </p:sp>
       <p:sp>
         <p:nvSpPr>
-          <p:cNvPr id="7" name="TextBox 6"/>
+          <p:cNvPr id="8" name="TextBox 7"/>
           <p:cNvSpPr txBox="1"/>
           <p:nvPr/>
         </p:nvSpPr>
@@ -3314,7 +3359,7 @@
       </p:sp>
       <p:sp>
         <p:nvSpPr>
-          <p:cNvPr id="8" name="Rectangle 7"/>
+          <p:cNvPr id="9" name="Rectangle 8"/>
           <p:cNvSpPr/>
           <p:nvPr/>
         </p:nvSpPr>
@@ -3359,7 +3404,7 @@
       </p:sp>
       <p:sp>
         <p:nvSpPr>
-          <p:cNvPr id="9" name="Rectangle 8"/>
+          <p:cNvPr id="10" name="Rectangle 9"/>
           <p:cNvSpPr/>
           <p:nvPr/>
         </p:nvSpPr>
@@ -3404,7 +3449,7 @@
       </p:sp>
       <p:sp>
         <p:nvSpPr>
-          <p:cNvPr id="10" name="TextBox 9"/>
+          <p:cNvPr id="11" name="TextBox 10"/>
           <p:cNvSpPr txBox="1"/>
           <p:nvPr/>
         </p:nvSpPr>
@@ -3437,7 +3482,7 @@
       </p:sp>
       <p:sp>
         <p:nvSpPr>
-          <p:cNvPr id="11" name="TextBox 10"/>
+          <p:cNvPr id="12" name="TextBox 11"/>
           <p:cNvSpPr txBox="1"/>
           <p:nvPr/>
         </p:nvSpPr>
@@ -3470,7 +3515,7 @@
       </p:sp>
       <p:sp>
         <p:nvSpPr>
-          <p:cNvPr id="12" name="TextBox 11"/>
+          <p:cNvPr id="13" name="TextBox 12"/>
           <p:cNvSpPr txBox="1"/>
           <p:nvPr/>
         </p:nvSpPr>
@@ -3503,7 +3548,7 @@
       </p:sp>
       <p:sp>
         <p:nvSpPr>
-          <p:cNvPr id="13" name="Rectangle 12"/>
+          <p:cNvPr id="14" name="Rectangle 13"/>
           <p:cNvSpPr/>
           <p:nvPr/>
         </p:nvSpPr>
@@ -3548,7 +3593,7 @@
       </p:sp>
       <p:sp>
         <p:nvSpPr>
-          <p:cNvPr id="14" name="Rectangle 13"/>
+          <p:cNvPr id="15" name="Rectangle 14"/>
           <p:cNvSpPr/>
           <p:nvPr/>
         </p:nvSpPr>
@@ -3593,7 +3638,7 @@
       </p:sp>
       <p:sp>
         <p:nvSpPr>
-          <p:cNvPr id="15" name="TextBox 14"/>
+          <p:cNvPr id="16" name="TextBox 15"/>
           <p:cNvSpPr txBox="1"/>
           <p:nvPr/>
         </p:nvSpPr>
@@ -3626,7 +3671,7 @@
       </p:sp>
       <p:sp>
         <p:nvSpPr>
-          <p:cNvPr id="16" name="TextBox 15"/>
+          <p:cNvPr id="17" name="TextBox 16"/>
           <p:cNvSpPr txBox="1"/>
           <p:nvPr/>
         </p:nvSpPr>
@@ -3659,7 +3704,7 @@
       </p:sp>
       <p:sp>
         <p:nvSpPr>
-          <p:cNvPr id="17" name="TextBox 16"/>
+          <p:cNvPr id="18" name="TextBox 17"/>
           <p:cNvSpPr txBox="1"/>
           <p:nvPr/>
         </p:nvSpPr>
@@ -3692,7 +3737,7 @@
       </p:sp>
       <p:sp>
         <p:nvSpPr>
-          <p:cNvPr id="18" name="Rectangle 17"/>
+          <p:cNvPr id="19" name="Rectangle 18"/>
           <p:cNvSpPr/>
           <p:nvPr/>
         </p:nvSpPr>
@@ -3737,7 +3782,7 @@
       </p:sp>
       <p:sp>
         <p:nvSpPr>
-          <p:cNvPr id="19" name="Rectangle 18"/>
+          <p:cNvPr id="20" name="Rectangle 19"/>
           <p:cNvSpPr/>
           <p:nvPr/>
         </p:nvSpPr>
@@ -3782,7 +3827,7 @@
       </p:sp>
       <p:sp>
         <p:nvSpPr>
-          <p:cNvPr id="20" name="TextBox 19"/>
+          <p:cNvPr id="21" name="TextBox 20"/>
           <p:cNvSpPr txBox="1"/>
           <p:nvPr/>
         </p:nvSpPr>
@@ -3815,7 +3860,7 @@
       </p:sp>
       <p:sp>
         <p:nvSpPr>
-          <p:cNvPr id="21" name="TextBox 20"/>
+          <p:cNvPr id="22" name="TextBox 21"/>
           <p:cNvSpPr txBox="1"/>
           <p:nvPr/>
         </p:nvSpPr>
@@ -3848,7 +3893,7 @@
       </p:sp>
       <p:sp>
         <p:nvSpPr>
-          <p:cNvPr id="22" name="TextBox 21"/>
+          <p:cNvPr id="23" name="TextBox 22"/>
           <p:cNvSpPr txBox="1"/>
           <p:nvPr/>
         </p:nvSpPr>
@@ -3881,7 +3926,7 @@
       </p:sp>
       <p:sp>
         <p:nvSpPr>
-          <p:cNvPr id="23" name="Rectangle 22"/>
+          <p:cNvPr id="24" name="Rectangle 23"/>
           <p:cNvSpPr/>
           <p:nvPr/>
         </p:nvSpPr>
@@ -3926,7 +3971,7 @@
       </p:sp>
       <p:sp>
         <p:nvSpPr>
-          <p:cNvPr id="24" name="Rectangle 23"/>
+          <p:cNvPr id="25" name="Rectangle 24"/>
           <p:cNvSpPr/>
           <p:nvPr/>
         </p:nvSpPr>
@@ -3971,7 +4016,7 @@
       </p:sp>
       <p:sp>
         <p:nvSpPr>
-          <p:cNvPr id="25" name="TextBox 24"/>
+          <p:cNvPr id="26" name="TextBox 25"/>
           <p:cNvSpPr txBox="1"/>
           <p:nvPr/>
         </p:nvSpPr>
@@ -4004,7 +4049,7 @@
       </p:sp>
       <p:sp>
         <p:nvSpPr>
-          <p:cNvPr id="26" name="TextBox 25"/>
+          <p:cNvPr id="27" name="TextBox 26"/>
           <p:cNvSpPr txBox="1"/>
           <p:nvPr/>
         </p:nvSpPr>
@@ -4037,7 +4082,7 @@
       </p:sp>
       <p:sp>
         <p:nvSpPr>
-          <p:cNvPr id="27" name="TextBox 26"/>
+          <p:cNvPr id="28" name="TextBox 27"/>
           <p:cNvSpPr txBox="1"/>
           <p:nvPr/>
         </p:nvSpPr>
@@ -4070,7 +4115,7 @@
       </p:sp>
       <p:sp>
         <p:nvSpPr>
-          <p:cNvPr id="28" name="TextBox 27"/>
+          <p:cNvPr id="29" name="TextBox 28"/>
           <p:cNvSpPr txBox="1"/>
           <p:nvPr/>
         </p:nvSpPr>
@@ -4103,7 +4148,7 @@
       </p:sp>
       <p:sp>
         <p:nvSpPr>
-          <p:cNvPr id="29" name="Rectangle 28"/>
+          <p:cNvPr id="30" name="Rectangle 29"/>
           <p:cNvSpPr/>
           <p:nvPr/>
         </p:nvSpPr>
@@ -4148,7 +4193,7 @@
       </p:sp>
       <p:sp>
         <p:nvSpPr>
-          <p:cNvPr id="30" name="Rectangle 29"/>
+          <p:cNvPr id="31" name="Rectangle 30"/>
           <p:cNvSpPr/>
           <p:nvPr/>
         </p:nvSpPr>
@@ -4193,7 +4238,7 @@
       </p:sp>
       <p:sp>
         <p:nvSpPr>
-          <p:cNvPr id="31" name="TextBox 30"/>
+          <p:cNvPr id="32" name="TextBox 31"/>
           <p:cNvSpPr txBox="1"/>
           <p:nvPr/>
         </p:nvSpPr>
@@ -4226,7 +4271,7 @@
       </p:sp>
       <p:sp>
         <p:nvSpPr>
-          <p:cNvPr id="32" name="TextBox 31"/>
+          <p:cNvPr id="33" name="TextBox 32"/>
           <p:cNvSpPr txBox="1"/>
           <p:nvPr/>
         </p:nvSpPr>
@@ -4259,7 +4304,7 @@
       </p:sp>
       <p:sp>
         <p:nvSpPr>
-          <p:cNvPr id="33" name="Rectangle 32"/>
+          <p:cNvPr id="34" name="Rectangle 33"/>
           <p:cNvSpPr/>
           <p:nvPr/>
         </p:nvSpPr>
@@ -4304,7 +4349,7 @@
       </p:sp>
       <p:sp>
         <p:nvSpPr>
-          <p:cNvPr id="34" name="Rectangle 33"/>
+          <p:cNvPr id="35" name="Rectangle 34"/>
           <p:cNvSpPr/>
           <p:nvPr/>
         </p:nvSpPr>
@@ -4349,7 +4394,7 @@
       </p:sp>
       <p:sp>
         <p:nvSpPr>
-          <p:cNvPr id="35" name="TextBox 34"/>
+          <p:cNvPr id="36" name="TextBox 35"/>
           <p:cNvSpPr txBox="1"/>
           <p:nvPr/>
         </p:nvSpPr>
@@ -4382,7 +4427,7 @@
       </p:sp>
       <p:sp>
         <p:nvSpPr>
-          <p:cNvPr id="36" name="TextBox 35"/>
+          <p:cNvPr id="37" name="TextBox 36"/>
           <p:cNvSpPr txBox="1"/>
           <p:nvPr/>
         </p:nvSpPr>
@@ -4415,7 +4460,7 @@
       </p:sp>
       <p:sp>
         <p:nvSpPr>
-          <p:cNvPr id="37" name="Rectangle 36"/>
+          <p:cNvPr id="38" name="Rectangle 37"/>
           <p:cNvSpPr/>
           <p:nvPr/>
         </p:nvSpPr>
@@ -4460,7 +4505,7 @@
       </p:sp>
       <p:sp>
         <p:nvSpPr>
-          <p:cNvPr id="38" name="Rectangle 37"/>
+          <p:cNvPr id="39" name="Rectangle 38"/>
           <p:cNvSpPr/>
           <p:nvPr/>
         </p:nvSpPr>
@@ -4505,7 +4550,7 @@
       </p:sp>
       <p:sp>
         <p:nvSpPr>
-          <p:cNvPr id="39" name="TextBox 38"/>
+          <p:cNvPr id="40" name="TextBox 39"/>
           <p:cNvSpPr txBox="1"/>
           <p:nvPr/>
         </p:nvSpPr>
@@ -4538,7 +4583,7 @@
       </p:sp>
       <p:sp>
         <p:nvSpPr>
-          <p:cNvPr id="40" name="TextBox 39"/>
+          <p:cNvPr id="41" name="TextBox 40"/>
           <p:cNvSpPr txBox="1"/>
           <p:nvPr/>
         </p:nvSpPr>
@@ -4571,7 +4616,7 @@
       </p:sp>
       <p:sp>
         <p:nvSpPr>
-          <p:cNvPr id="41" name="Rectangle 40"/>
+          <p:cNvPr id="42" name="Rectangle 41"/>
           <p:cNvSpPr/>
           <p:nvPr/>
         </p:nvSpPr>
@@ -4616,7 +4661,7 @@
       </p:sp>
       <p:sp>
         <p:nvSpPr>
-          <p:cNvPr id="42" name="Rectangle 41"/>
+          <p:cNvPr id="43" name="Rectangle 42"/>
           <p:cNvSpPr/>
           <p:nvPr/>
         </p:nvSpPr>
@@ -4661,7 +4706,7 @@
       </p:sp>
       <p:sp>
         <p:nvSpPr>
-          <p:cNvPr id="43" name="TextBox 42"/>
+          <p:cNvPr id="44" name="TextBox 43"/>
           <p:cNvSpPr txBox="1"/>
           <p:nvPr/>
         </p:nvSpPr>
@@ -4694,7 +4739,7 @@
       </p:sp>
       <p:sp>
         <p:nvSpPr>
-          <p:cNvPr id="44" name="TextBox 43"/>
+          <p:cNvPr id="45" name="TextBox 44"/>
           <p:cNvSpPr txBox="1"/>
           <p:nvPr/>
         </p:nvSpPr>
@@ -4727,14 +4772,14 @@
       </p:sp>
       <p:sp>
         <p:nvSpPr>
-          <p:cNvPr id="45" name="Rectangle 44"/>
+          <p:cNvPr id="46" name="Rectangle 45"/>
           <p:cNvSpPr/>
           <p:nvPr/>
         </p:nvSpPr>
         <p:spPr>
           <a:xfrm>
-            <a:off x="5257800" y="0"/>
-            <a:ext cx="3886200" cy="4828032"/>
+            <a:off x="5257800" y="960120"/>
+            <a:ext cx="3886200" cy="3867912"/>
           </a:xfrm>
           <a:prstGeom prst="rect">
             <a:avLst/>
@@ -4772,13 +4817,13 @@
       </p:sp>
       <p:sp>
         <p:nvSpPr>
-          <p:cNvPr id="46" name="Rectangle 45"/>
+          <p:cNvPr id="47" name="Rectangle 46"/>
           <p:cNvSpPr/>
           <p:nvPr/>
         </p:nvSpPr>
         <p:spPr>
           <a:xfrm>
-            <a:off x="5257800" y="2267712"/>
+            <a:off x="5257800" y="1024128"/>
             <a:ext cx="3886200" cy="694944"/>
           </a:xfrm>
           <a:prstGeom prst="rect">
@@ -4817,13 +4862,13 @@
       </p:sp>
       <p:sp>
         <p:nvSpPr>
-          <p:cNvPr id="47" name="Rectangle 46"/>
+          <p:cNvPr id="48" name="Rectangle 47"/>
           <p:cNvSpPr/>
           <p:nvPr/>
         </p:nvSpPr>
         <p:spPr>
           <a:xfrm>
-            <a:off x="5257800" y="2267712"/>
+            <a:off x="5257800" y="1024128"/>
             <a:ext cx="128016" cy="694944"/>
           </a:xfrm>
           <a:prstGeom prst="rect">
@@ -4862,13 +4907,13 @@
       </p:sp>
       <p:sp>
         <p:nvSpPr>
-          <p:cNvPr id="48" name="TextBox 47"/>
-          <p:cNvSpPr txBox="1"/>
-          <p:nvPr/>
-        </p:nvSpPr>
-        <p:spPr>
-          <a:xfrm>
-            <a:off x="5486400" y="2286000"/>
+          <p:cNvPr id="49" name="TextBox 48"/>
+          <p:cNvSpPr txBox="1"/>
+          <p:nvPr/>
+        </p:nvSpPr>
+        <p:spPr>
+          <a:xfrm>
+            <a:off x="5486400" y="1042415"/>
             <a:ext cx="3474720" cy="201168"/>
           </a:xfrm>
           <a:prstGeom prst="rect">
@@ -4895,13 +4940,13 @@
       </p:sp>
       <p:sp>
         <p:nvSpPr>
-          <p:cNvPr id="49" name="TextBox 48"/>
-          <p:cNvSpPr txBox="1"/>
-          <p:nvPr/>
-        </p:nvSpPr>
-        <p:spPr>
-          <a:xfrm>
-            <a:off x="5486400" y="2487168"/>
+          <p:cNvPr id="50" name="TextBox 49"/>
+          <p:cNvSpPr txBox="1"/>
+          <p:nvPr/>
+        </p:nvSpPr>
+        <p:spPr>
+          <a:xfrm>
+            <a:off x="5486400" y="1243584"/>
             <a:ext cx="3474720" cy="402336"/>
           </a:xfrm>
           <a:prstGeom prst="rect">
@@ -4928,13 +4973,13 @@
       </p:sp>
       <p:sp>
         <p:nvSpPr>
-          <p:cNvPr id="50" name="TextBox 49"/>
-          <p:cNvSpPr txBox="1"/>
-          <p:nvPr/>
-        </p:nvSpPr>
-        <p:spPr>
-          <a:xfrm>
-            <a:off x="5394960" y="3063240"/>
+          <p:cNvPr id="51" name="TextBox 50"/>
+          <p:cNvSpPr txBox="1"/>
+          <p:nvPr/>
+        </p:nvSpPr>
+        <p:spPr>
+          <a:xfrm>
+            <a:off x="5394960" y="1920240"/>
             <a:ext cx="3566160" cy="219456"/>
           </a:xfrm>
           <a:prstGeom prst="rect">
@@ -4961,13 +5006,13 @@
       </p:sp>
       <p:sp>
         <p:nvSpPr>
-          <p:cNvPr id="51" name="Rectangle 50"/>
+          <p:cNvPr id="52" name="Rectangle 51"/>
           <p:cNvSpPr/>
           <p:nvPr/>
         </p:nvSpPr>
         <p:spPr>
           <a:xfrm>
-            <a:off x="5257800" y="3310128"/>
+            <a:off x="5257800" y="2176272"/>
             <a:ext cx="3886200" cy="310896"/>
           </a:xfrm>
           <a:prstGeom prst="rect">
@@ -5006,13 +5051,13 @@
       </p:sp>
       <p:sp>
         <p:nvSpPr>
-          <p:cNvPr id="52" name="TextBox 51"/>
-          <p:cNvSpPr txBox="1"/>
-          <p:nvPr/>
-        </p:nvSpPr>
-        <p:spPr>
-          <a:xfrm>
-            <a:off x="5413248" y="3355848"/>
+          <p:cNvPr id="53" name="TextBox 52"/>
+          <p:cNvSpPr txBox="1"/>
+          <p:nvPr/>
+        </p:nvSpPr>
+        <p:spPr>
+          <a:xfrm>
+            <a:off x="5413248" y="2221991"/>
             <a:ext cx="1828800" cy="219456"/>
           </a:xfrm>
           <a:prstGeom prst="rect">
@@ -5039,13 +5084,13 @@
       </p:sp>
       <p:sp>
         <p:nvSpPr>
-          <p:cNvPr id="53" name="TextBox 52"/>
-          <p:cNvSpPr txBox="1"/>
-          <p:nvPr/>
-        </p:nvSpPr>
-        <p:spPr>
-          <a:xfrm>
-            <a:off x="7260336" y="3355848"/>
+          <p:cNvPr id="54" name="TextBox 53"/>
+          <p:cNvSpPr txBox="1"/>
+          <p:nvPr/>
+        </p:nvSpPr>
+        <p:spPr>
+          <a:xfrm>
+            <a:off x="7260336" y="2221991"/>
             <a:ext cx="914400" cy="219456"/>
           </a:xfrm>
           <a:prstGeom prst="rect">
@@ -5072,13 +5117,13 @@
       </p:sp>
       <p:sp>
         <p:nvSpPr>
-          <p:cNvPr id="54" name="TextBox 53"/>
-          <p:cNvSpPr txBox="1"/>
-          <p:nvPr/>
-        </p:nvSpPr>
-        <p:spPr>
-          <a:xfrm>
-            <a:off x="8193024" y="3374136"/>
+          <p:cNvPr id="55" name="TextBox 54"/>
+          <p:cNvSpPr txBox="1"/>
+          <p:nvPr/>
+        </p:nvSpPr>
+        <p:spPr>
+          <a:xfrm>
+            <a:off x="8193024" y="2240279"/>
             <a:ext cx="822960" cy="201168"/>
           </a:xfrm>
           <a:prstGeom prst="rect">
@@ -5105,13 +5150,13 @@
       </p:sp>
       <p:sp>
         <p:nvSpPr>
-          <p:cNvPr id="55" name="Rectangle 54"/>
+          <p:cNvPr id="56" name="Rectangle 55"/>
           <p:cNvSpPr/>
           <p:nvPr/>
         </p:nvSpPr>
         <p:spPr>
           <a:xfrm>
-            <a:off x="5257800" y="3657600"/>
+            <a:off x="5257800" y="2523744"/>
             <a:ext cx="3886200" cy="310896"/>
           </a:xfrm>
           <a:prstGeom prst="rect">
@@ -5150,13 +5195,13 @@
       </p:sp>
       <p:sp>
         <p:nvSpPr>
-          <p:cNvPr id="56" name="TextBox 55"/>
-          <p:cNvSpPr txBox="1"/>
-          <p:nvPr/>
-        </p:nvSpPr>
-        <p:spPr>
-          <a:xfrm>
-            <a:off x="5413248" y="3703320"/>
+          <p:cNvPr id="57" name="TextBox 56"/>
+          <p:cNvSpPr txBox="1"/>
+          <p:nvPr/>
+        </p:nvSpPr>
+        <p:spPr>
+          <a:xfrm>
+            <a:off x="5413248" y="2569463"/>
             <a:ext cx="1828800" cy="219456"/>
           </a:xfrm>
           <a:prstGeom prst="rect">
@@ -5183,13 +5228,13 @@
       </p:sp>
       <p:sp>
         <p:nvSpPr>
-          <p:cNvPr id="57" name="TextBox 56"/>
-          <p:cNvSpPr txBox="1"/>
-          <p:nvPr/>
-        </p:nvSpPr>
-        <p:spPr>
-          <a:xfrm>
-            <a:off x="7260336" y="3703320"/>
+          <p:cNvPr id="58" name="TextBox 57"/>
+          <p:cNvSpPr txBox="1"/>
+          <p:nvPr/>
+        </p:nvSpPr>
+        <p:spPr>
+          <a:xfrm>
+            <a:off x="7260336" y="2569463"/>
             <a:ext cx="914400" cy="219456"/>
           </a:xfrm>
           <a:prstGeom prst="rect">
@@ -5216,13 +5261,13 @@
       </p:sp>
       <p:sp>
         <p:nvSpPr>
-          <p:cNvPr id="58" name="TextBox 57"/>
-          <p:cNvSpPr txBox="1"/>
-          <p:nvPr/>
-        </p:nvSpPr>
-        <p:spPr>
-          <a:xfrm>
-            <a:off x="8193024" y="3721608"/>
+          <p:cNvPr id="59" name="TextBox 58"/>
+          <p:cNvSpPr txBox="1"/>
+          <p:nvPr/>
+        </p:nvSpPr>
+        <p:spPr>
+          <a:xfrm>
+            <a:off x="8193024" y="2587751"/>
             <a:ext cx="822960" cy="201168"/>
           </a:xfrm>
           <a:prstGeom prst="rect">
@@ -5249,13 +5294,13 @@
       </p:sp>
       <p:sp>
         <p:nvSpPr>
-          <p:cNvPr id="59" name="Rectangle 58"/>
+          <p:cNvPr id="60" name="Rectangle 59"/>
           <p:cNvSpPr/>
           <p:nvPr/>
         </p:nvSpPr>
         <p:spPr>
           <a:xfrm>
-            <a:off x="5257800" y="4005072"/>
+            <a:off x="5257800" y="2871216"/>
             <a:ext cx="3886200" cy="310896"/>
           </a:xfrm>
           <a:prstGeom prst="rect">
@@ -5294,13 +5339,13 @@
       </p:sp>
       <p:sp>
         <p:nvSpPr>
-          <p:cNvPr id="60" name="TextBox 59"/>
-          <p:cNvSpPr txBox="1"/>
-          <p:nvPr/>
-        </p:nvSpPr>
-        <p:spPr>
-          <a:xfrm>
-            <a:off x="5413248" y="4050791"/>
+          <p:cNvPr id="61" name="TextBox 60"/>
+          <p:cNvSpPr txBox="1"/>
+          <p:nvPr/>
+        </p:nvSpPr>
+        <p:spPr>
+          <a:xfrm>
+            <a:off x="5413248" y="2916936"/>
             <a:ext cx="1828800" cy="219456"/>
           </a:xfrm>
           <a:prstGeom prst="rect">
@@ -5327,13 +5372,13 @@
       </p:sp>
       <p:sp>
         <p:nvSpPr>
-          <p:cNvPr id="61" name="TextBox 60"/>
-          <p:cNvSpPr txBox="1"/>
-          <p:nvPr/>
-        </p:nvSpPr>
-        <p:spPr>
-          <a:xfrm>
-            <a:off x="7260336" y="4050791"/>
+          <p:cNvPr id="62" name="TextBox 61"/>
+          <p:cNvSpPr txBox="1"/>
+          <p:nvPr/>
+        </p:nvSpPr>
+        <p:spPr>
+          <a:xfrm>
+            <a:off x="7260336" y="2916936"/>
             <a:ext cx="914400" cy="219456"/>
           </a:xfrm>
           <a:prstGeom prst="rect">
@@ -5360,13 +5405,13 @@
       </p:sp>
       <p:sp>
         <p:nvSpPr>
-          <p:cNvPr id="62" name="TextBox 61"/>
-          <p:cNvSpPr txBox="1"/>
-          <p:nvPr/>
-        </p:nvSpPr>
-        <p:spPr>
-          <a:xfrm>
-            <a:off x="8193024" y="4069080"/>
+          <p:cNvPr id="63" name="TextBox 62"/>
+          <p:cNvSpPr txBox="1"/>
+          <p:nvPr/>
+        </p:nvSpPr>
+        <p:spPr>
+          <a:xfrm>
+            <a:off x="8193024" y="2935224"/>
             <a:ext cx="822960" cy="201168"/>
           </a:xfrm>
           <a:prstGeom prst="rect">
@@ -5393,13 +5438,13 @@
       </p:sp>
       <p:sp>
         <p:nvSpPr>
-          <p:cNvPr id="63" name="Rectangle 62"/>
+          <p:cNvPr id="64" name="Rectangle 63"/>
           <p:cNvSpPr/>
           <p:nvPr/>
         </p:nvSpPr>
         <p:spPr>
           <a:xfrm>
-            <a:off x="5257800" y="4352544"/>
+            <a:off x="5257800" y="3218688"/>
             <a:ext cx="3886200" cy="310896"/>
           </a:xfrm>
           <a:prstGeom prst="rect">
@@ -5438,13 +5483,13 @@
       </p:sp>
       <p:sp>
         <p:nvSpPr>
-          <p:cNvPr id="64" name="Rectangle 63"/>
+          <p:cNvPr id="65" name="Rectangle 64"/>
           <p:cNvSpPr/>
           <p:nvPr/>
         </p:nvSpPr>
         <p:spPr>
           <a:xfrm>
-            <a:off x="5257800" y="4352544"/>
+            <a:off x="5257800" y="3218688"/>
             <a:ext cx="91440" cy="310896"/>
           </a:xfrm>
           <a:prstGeom prst="rect">
@@ -5483,13 +5528,13 @@
       </p:sp>
       <p:sp>
         <p:nvSpPr>
-          <p:cNvPr id="65" name="TextBox 64"/>
-          <p:cNvSpPr txBox="1"/>
-          <p:nvPr/>
-        </p:nvSpPr>
-        <p:spPr>
-          <a:xfrm>
-            <a:off x="5413248" y="4398264"/>
+          <p:cNvPr id="66" name="TextBox 65"/>
+          <p:cNvSpPr txBox="1"/>
+          <p:nvPr/>
+        </p:nvSpPr>
+        <p:spPr>
+          <a:xfrm>
+            <a:off x="5413248" y="3264408"/>
             <a:ext cx="1828800" cy="219456"/>
           </a:xfrm>
           <a:prstGeom prst="rect">
@@ -5516,13 +5561,13 @@
       </p:sp>
       <p:sp>
         <p:nvSpPr>
-          <p:cNvPr id="66" name="TextBox 65"/>
-          <p:cNvSpPr txBox="1"/>
-          <p:nvPr/>
-        </p:nvSpPr>
-        <p:spPr>
-          <a:xfrm>
-            <a:off x="7260336" y="4398264"/>
+          <p:cNvPr id="67" name="TextBox 66"/>
+          <p:cNvSpPr txBox="1"/>
+          <p:nvPr/>
+        </p:nvSpPr>
+        <p:spPr>
+          <a:xfrm>
+            <a:off x="7260336" y="3264408"/>
             <a:ext cx="914400" cy="219456"/>
           </a:xfrm>
           <a:prstGeom prst="rect">
@@ -5549,13 +5594,13 @@
       </p:sp>
       <p:sp>
         <p:nvSpPr>
-          <p:cNvPr id="67" name="TextBox 66"/>
-          <p:cNvSpPr txBox="1"/>
-          <p:nvPr/>
-        </p:nvSpPr>
-        <p:spPr>
-          <a:xfrm>
-            <a:off x="8193024" y="4416552"/>
+          <p:cNvPr id="68" name="TextBox 67"/>
+          <p:cNvSpPr txBox="1"/>
+          <p:nvPr/>
+        </p:nvSpPr>
+        <p:spPr>
+          <a:xfrm>
+            <a:off x="8193024" y="3282696"/>
             <a:ext cx="822960" cy="201168"/>
           </a:xfrm>
           <a:prstGeom prst="rect">
@@ -5582,7 +5627,7 @@
       </p:sp>
       <p:sp>
         <p:nvSpPr>
-          <p:cNvPr id="68" name="Rectangle 67"/>
+          <p:cNvPr id="69" name="Rectangle 68"/>
           <p:cNvSpPr/>
           <p:nvPr/>
         </p:nvSpPr>
@@ -5627,7 +5672,7 @@
       </p:sp>
       <p:pic>
         <p:nvPicPr>
-          <p:cNvPr id="69" name="Picture 68" descr="smb_team_logo.png"/>
+          <p:cNvPr id="70" name="Picture 69" descr="smb_team_logo.png"/>
           <p:cNvPicPr>
             <a:picLocks noChangeAspect="1"/>
           </p:cNvPicPr>
@@ -5651,7 +5696,7 @@
       </p:pic>
       <p:sp>
         <p:nvSpPr>
-          <p:cNvPr id="70" name="TextBox 69"/>
+          <p:cNvPr id="71" name="TextBox 70"/>
           <p:cNvSpPr txBox="1"/>
           <p:nvPr/>
         </p:nvSpPr>
@@ -5684,7 +5729,7 @@
       </p:sp>
       <p:sp>
         <p:nvSpPr>
-          <p:cNvPr id="71" name="TextBox 70"/>
+          <p:cNvPr id="72" name="TextBox 71"/>
           <p:cNvSpPr txBox="1"/>
           <p:nvPr/>
         </p:nvSpPr>
@@ -5897,7 +5942,7 @@
         </p:nvSpPr>
         <p:spPr>
           <a:xfrm>
-            <a:off x="182880" y="2450592"/>
+            <a:off x="182880" y="1042415"/>
             <a:ext cx="2487168" cy="18288"/>
           </a:xfrm>
           <a:prstGeom prst="rect">
@@ -5942,7 +5987,7 @@
         </p:nvSpPr>
         <p:spPr>
           <a:xfrm>
-            <a:off x="292608" y="2523744"/>
+            <a:off x="292608" y="1097280"/>
             <a:ext cx="2267712" cy="201168"/>
           </a:xfrm>
           <a:prstGeom prst="rect">
@@ -5975,8 +6020,8 @@
         </p:nvSpPr>
         <p:spPr>
           <a:xfrm>
-            <a:off x="292608" y="2743200"/>
-            <a:ext cx="2267712" cy="658368"/>
+            <a:off x="292608" y="1335024"/>
+            <a:ext cx="2267712" cy="1572768"/>
           </a:xfrm>
           <a:prstGeom prst="rect">
             <a:avLst/>
@@ -6008,8 +6053,8 @@
         </p:nvSpPr>
         <p:spPr>
           <a:xfrm>
-            <a:off x="182880" y="3456432"/>
-            <a:ext cx="2487168" cy="658368"/>
+            <a:off x="182880" y="2999232"/>
+            <a:ext cx="2487168" cy="749808"/>
           </a:xfrm>
           <a:prstGeom prst="rect">
             <a:avLst/>
@@ -6053,7 +6098,7 @@
         </p:nvSpPr>
         <p:spPr>
           <a:xfrm>
-            <a:off x="292608" y="3474720"/>
+            <a:off x="292608" y="3017520"/>
             <a:ext cx="2286000" cy="274320"/>
           </a:xfrm>
           <a:prstGeom prst="rect">
@@ -6086,8 +6131,8 @@
         </p:nvSpPr>
         <p:spPr>
           <a:xfrm>
-            <a:off x="292608" y="3749039"/>
-            <a:ext cx="2286000" cy="329184"/>
+            <a:off x="292608" y="3291840"/>
+            <a:ext cx="2286000" cy="402336"/>
           </a:xfrm>
           <a:prstGeom prst="rect">
             <a:avLst/>

</xml_diff>